<commit_message>
docs: humanize submission prose (dash-free, de-AI'd) + portable technical deck PDF
Report, README, docs, and both decks rewritten to read naturally and carry
zero em/en dashes or arrow glyphs. An adversarial per-document check confirmed
humanization changed only wording: every number, CI, metric, figure reference,
and claim is preserved (verified against the pre-humanization version). Adds
presentations/technical_deck.pdf (portable, one landscape page per slide) so
the technical deck is viewable without a browser. 38 tests pass; lint clean.
</commit_message>
<xml_diff>
--- a/presentations/business_deck.pptx
+++ b/presentations/business_deck.pptx
@@ -3479,7 +3479,7 @@
               </a:defRPr>
             </a:pPr>
             <a:r>
-              <a:t>• Olist's pitch to small merchants is exposure — a bestseller-only storefront quietly breaks that promise.</a:t>
+              <a:t>• Olist sells small merchants on exposure. A bestseller-only storefront quietly breaks that promise.</a:t>
             </a:r>
           </a:p>
           <a:p>
@@ -3730,7 +3730,7 @@
               </a:defRPr>
             </a:pPr>
             <a:r>
-              <a:t>• Returning customers arrive with history — they're exactly the ones a recommender can serve well.</a:t>
+              <a:t>• Returning customers arrive with history, so they're exactly the ones a recommender can serve well.</a:t>
             </a:r>
           </a:p>
           <a:p>
@@ -3883,7 +3883,7 @@
               </a:defRPr>
             </a:pPr>
             <a:r>
-              <a:t>What the engine does — no math required</a:t>
+              <a:t>What the engine does (no math required)</a:t>
             </a:r>
           </a:p>
         </p:txBody>
@@ -3921,7 +3921,7 @@
               </a:defRPr>
             </a:pPr>
             <a:r>
-              <a:t>• Step 1 — builds a shortlist: products similar to what you've bought, plus what shoppers like you buy.</a:t>
+              <a:t>• Step 1 builds a shortlist: products similar to what you've bought, plus what shoppers like you buy.</a:t>
             </a:r>
           </a:p>
           <a:p>
@@ -3936,7 +3936,7 @@
               </a:defRPr>
             </a:pPr>
             <a:r>
-              <a:t>• Step 2 — ranks the shortlist: a model scores how likely you are to actually purchase each item.</a:t>
+              <a:t>• Step 2 ranks the shortlist: a model scores how likely you are to buy each item.</a:t>
             </a:r>
           </a:p>
           <a:p>
@@ -3951,7 +3951,7 @@
               </a:defRPr>
             </a:pPr>
             <a:r>
-              <a:t>• Brand-new visitor? It falls back gracefully: bestsellers for your region, or overall.</a:t>
+              <a:t>• For a brand-new visitor, it falls back gracefully: bestsellers for your region, or overall.</a:t>
             </a:r>
           </a:p>
           <a:p>
@@ -3966,7 +3966,7 @@
               </a:defRPr>
             </a:pPr>
             <a:r>
-              <a:t>• Every recommendation can explain itself in one plain sentence — "why you're seeing this".</a:t>
+              <a:t>• Every recommendation can explain itself in one plain sentence: "why you're seeing this".</a:t>
             </a:r>
           </a:p>
           <a:p>
@@ -3981,7 +3981,7 @@
               </a:defRPr>
             </a:pPr>
             <a:r>
-              <a:t>• Runs as a small web service in a container — serving exactly the pipeline the evaluation graded.</a:t>
+              <a:t>• Runs as a small web service in a container, serving exactly the pipeline the evaluation graded.</a:t>
             </a:r>
           </a:p>
         </p:txBody>
@@ -4277,7 +4277,7 @@
               </a:defRPr>
             </a:pPr>
             <a:r>
-              <a:t>What the evaluation says — honestly</a:t>
+              <a:t>What the evaluation says, honestly</a:t>
             </a:r>
           </a:p>
         </p:txBody>
@@ -4328,11 +4328,11 @@
             </a:r>
             <a:br/>
             <a:r>
-              <a:t>purchase in the top-10 shortlist</a:t>
+              <a:t>purchase in the top-10 shortlist,</a:t>
             </a:r>
             <a:br/>
             <a:r>
-              <a:t>— vs 1 in 32 with bestsellers</a:t>
+              <a:t>vs 1 in 32 with bestsellers</a:t>
             </a:r>
           </a:p>
         </p:txBody>
@@ -4438,7 +4438,7 @@
             </a:r>
             <a:br/>
             <a:r>
-              <a:t>returning buyers' shortlists —</a:t>
+              <a:t>returning buyers' shortlists;</a:t>
             </a:r>
             <a:br/>
             <a:r>
@@ -4495,7 +4495,7 @@
               </a:defRPr>
             </a:pPr>
             <a:r>
-              <a:t>• All numbers are offline estimates — the honest next step is a live A/B test, and the rollout plan is built around one.</a:t>
+              <a:t>• All numbers are offline estimates. The honest next step is a live A/B test, and the rollout plan is built around one.</a:t>
             </a:r>
           </a:p>
         </p:txBody>
@@ -4530,7 +4530,7 @@
               </a:defRPr>
             </a:pPr>
             <a:r>
-              <a:t>For the technical appendix: shortlist hit rate 0.203 vs 0.031 popularity (leave-last-order-out, 1,949 repeat buyers); end-to-end +0.0024 [+0.0008, +0.0041] Hit@10 vs shortlist-only; shortlist coverage 0.371; live top-10 coverage 0.071 → 0.102 with the seller dial.</a:t>
+              <a:t>For the technical appendix: shortlist hit rate 0.203 vs 0.031 popularity (leave-last-order-out, 1,949 repeat buyers); end-to-end +0.0024 [+0.0008, +0.0041] Hit@10 vs shortlist-only; shortlist coverage 0.371; live top-10 coverage 0.071 to 0.102 with the seller dial.</a:t>
             </a:r>
           </a:p>
         </p:txBody>
@@ -4656,7 +4656,7 @@
               </a:defRPr>
             </a:pPr>
             <a:r>
-              <a:t>• Recommendation quality is not uniform: Northeast customers currently get the best results — found, explained (it starts in the shortlist stage), and monitored.</a:t>
+              <a:t>• Recommendation quality is not uniform: Northeast customers currently get the best results. We found it, traced it to the shortlist stage, and monitor it.</a:t>
             </a:r>
           </a:p>
           <a:p>
@@ -4671,7 +4671,7 @@
               </a:defRPr>
             </a:pPr>
             <a:r>
-              <a:t>• Without intervention, small sellers (5.9% of the catalogue) receive 0.02% of top-10 slots — a direct risk to the exposure promise.</a:t>
+              <a:t>• Without intervention, small sellers (5.9% of the catalogue) receive 0.02% of top-10 slots, a direct risk to the exposure promise.</a:t>
             </a:r>
           </a:p>
           <a:p>
@@ -4701,7 +4701,7 @@
               </a:defRPr>
             </a:pPr>
             <a:r>
-              <a:t>– Keep all 10 slots for relevance → best hit rate, near-zero small-seller exposure</a:t>
+              <a:t>◦ Keep all 10 slots for relevance: best hit rate, near-zero small-seller exposure</a:t>
             </a:r>
           </a:p>
           <a:p>
@@ -4716,7 +4716,7 @@
               </a:defRPr>
             </a:pPr>
             <a:r>
-              <a:t>– Reserve 3 of 10 slots for under-exposed products → small sellers ×4.3, rarely-shown products ×2.1, at ~15% hit-rate cost</a:t>
+              <a:t>◦ Reserve 3 of 10 slots for under-exposed products: small sellers ×4.3, rarely-shown products ×2.1, at ~15% hit-rate cost</a:t>
             </a:r>
           </a:p>
           <a:p>
@@ -4731,7 +4731,7 @@
               </a:defRPr>
             </a:pPr>
             <a:r>
-              <a:t>– Southern customers pay the most for that dial — quantified, so the trade-off is a decision, not an accident</a:t>
+              <a:t>◦ Southern customers pay the most for that dial, quantified, so the trade-off is a decision, not an accident</a:t>
             </a:r>
           </a:p>
         </p:txBody>
@@ -4931,7 +4931,7 @@
               </a:defRPr>
             </a:pPr>
             <a:r>
-              <a:t>• No demographics used anywhere — geography is audited precisely because it proxies income.</a:t>
+              <a:t>• No demographics used anywhere. Geography is audited precisely because it proxies income.</a:t>
             </a:r>
           </a:p>
           <a:p>
@@ -5102,7 +5102,7 @@
               </a:defRPr>
             </a:pPr>
             <a:r>
-              <a:t>• Phase 1 — shadow mode (2–4 weeks): serve recommendations silently, compare against actual purchases.</a:t>
+              <a:t>• Phase 1, shadow mode (2 to 4 weeks): serve recommendations silently and compare against actual purchases.</a:t>
             </a:r>
           </a:p>
           <a:p>
@@ -5117,7 +5117,7 @@
               </a:defRPr>
             </a:pPr>
             <a:r>
-              <a:t>• Phase 2 — A/B test on returning buyers: recommendation rail vs bestseller rail; primary metric = repeat-purchase rate.</a:t>
+              <a:t>• Phase 2, A/B test on returning buyers: recommendation rail vs bestseller rail; primary metric = repeat-purchase rate.</a:t>
             </a:r>
           </a:p>
           <a:p>
@@ -5132,7 +5132,7 @@
               </a:defRPr>
             </a:pPr>
             <a:r>
-              <a:t>• Phase 3 — regional merchandising for new visitors, measured on first-purchase cross-sell.</a:t>
+              <a:t>• Phase 3, regional merchandising for new visitors, measured on first-purchase cross-sell.</a:t>
             </a:r>
           </a:p>
           <a:p>
@@ -5147,7 +5147,7 @@
               </a:defRPr>
             </a:pPr>
             <a:r>
-              <a:t>• Phase 4 — seller-exposure dial, set with the merchant team after validating on newer data.</a:t>
+              <a:t>• Phase 4, seller-exposure dial, set with the merchant team after validating on newer data.</a:t>
             </a:r>
           </a:p>
           <a:p>
@@ -5511,7 +5511,7 @@
               </a:defRPr>
             </a:pPr>
             <a:r>
-              <a:t>– Offline results may not transfer online — that's why phase 1 is shadow mode.</a:t>
+              <a:t>◦ Offline results may not transfer online, which is why phase 1 is shadow mode.</a:t>
             </a:r>
           </a:p>
           <a:p>
@@ -5526,7 +5526,7 @@
               </a:defRPr>
             </a:pPr>
             <a:r>
-              <a:t>– Recommenders amplify what they show: popularity feedback loops — exposure metrics watch for this monthly.</a:t>
+              <a:t>◦ Recommenders amplify what they show, so popularity feedback loops are a risk; exposure metrics watch for this monthly.</a:t>
             </a:r>
           </a:p>
           <a:p>
@@ -5541,7 +5541,7 @@
               </a:defRPr>
             </a:pPr>
             <a:r>
-              <a:t>– Personalisation reach is small today (~3%); growing it depends on retention improving — the two compound.</a:t>
+              <a:t>◦ Personalisation reach is small today (~3%), and growing it depends on retention improving; the two compound.</a:t>
             </a:r>
           </a:p>
           <a:p>
@@ -5571,7 +5571,7 @@
               </a:defRPr>
             </a:pPr>
             <a:r>
-              <a:t>– An A/B testing slot on the storefront and click/purchase telemetry for the live hit rate.</a:t>
+              <a:t>◦ An A/B testing slot on the storefront and click/purchase telemetry for the live hit rate.</a:t>
             </a:r>
           </a:p>
           <a:p>
@@ -5586,7 +5586,7 @@
               </a:defRPr>
             </a:pPr>
             <a:r>
-              <a:t>– A product owner for the seller-exposure dial.</a:t>
+              <a:t>◦ A product owner for the seller-exposure dial.</a:t>
             </a:r>
           </a:p>
           <a:p>
@@ -5601,7 +5601,7 @@
               </a:defRPr>
             </a:pPr>
             <a:r>
-              <a:t>– A decision review after phase 2 with the live numbers on the table.</a:t>
+              <a:t>◦ A decision review after phase 2 with the live numbers on the table.</a:t>
             </a:r>
           </a:p>
         </p:txBody>

</xml_diff>

<commit_message>
style: US English + no em dashes across docs, comments, docstrings, decks
Convert British spellings to US and remove em/en dashes throughout authored
prose, code comments, docstrings, and the deck display text (explicit word
map, so supervise/merchandise/comprise are untouched). Code identifiers,
dict keys, dataset column names, and figure-bound plot/print strings are
unchanged; docs/llm LLM-evidence files are left verbatim. Regenerated the
business/technical decks and report PDF from the converted sources. 38 tests
pass; only src/tests/app are linted by CI and remain clean.
</commit_message>
<xml_diff>
--- a/presentations/business_deck.pptx
+++ b/presentations/business_deck.pptx
@@ -3494,7 +3494,7 @@
               </a:defRPr>
             </a:pPr>
             <a:r>
-              <a:t>• Today there is no personalisation: every visitor sees the same popular products.</a:t>
+              <a:t>• Today there is no personalization: every visitor sees the same popular products.</a:t>
             </a:r>
           </a:p>
         </p:txBody>
@@ -3745,7 +3745,7 @@
               </a:defRPr>
             </a:pPr>
             <a:r>
-              <a:t>• For the single-purchase majority, the win is smarter first-purchase cross-sell and regional merchandising, not personalisation.</a:t>
+              <a:t>• For the single-purchase majority, the win is smarter first-purchase cross-sell and regional merchandising, not personalization.</a:t>
             </a:r>
           </a:p>
           <a:p>
@@ -3795,7 +3795,7 @@
               </a:defRPr>
             </a:pPr>
             <a:r>
-              <a:t>Scope honesty: personalisation applies to the ~3% with history today; the engine handles everyone, but with different tools.</a:t>
+              <a:t>Scope honesty: personalization applies to the ~3% with history today; the engine handles everyone, but with different tools.</a:t>
             </a:r>
           </a:p>
         </p:txBody>
@@ -4434,7 +4434,7 @@
               </a:defRPr>
             </a:pPr>
             <a:r>
-              <a:t>of the catalogue reachable in</a:t>
+              <a:t>of the catalog reachable in</a:t>
             </a:r>
             <a:br/>
             <a:r>
@@ -4480,7 +4480,7 @@
               </a:defRPr>
             </a:pPr>
             <a:r>
-              <a:t>• Two test beds, labelled honestly: shortlist quality is graded on returning buyers' held-out orders; the deployed pipeline on a strictly past-only three-month holdout.</a:t>
+              <a:t>• Two test beds, labeled honestly: shortlist quality is graded on returning buyers' held-out orders; the deployed pipeline on a strictly past-only three-month holdout.</a:t>
             </a:r>
           </a:p>
           <a:p>
@@ -4671,7 +4671,7 @@
               </a:defRPr>
             </a:pPr>
             <a:r>
-              <a:t>• Without intervention, small sellers (5.9% of the catalogue) receive 0.02% of top-10 slots, a direct risk to the exposure promise.</a:t>
+              <a:t>• Without intervention, small sellers (5.9% of the catalog) receive 0.02% of top-10 slots, a direct risk to the exposure promise.</a:t>
             </a:r>
           </a:p>
           <a:p>
@@ -5541,7 +5541,7 @@
               </a:defRPr>
             </a:pPr>
             <a:r>
-              <a:t>◦ Personalisation reach is small today (~3%), and growing it depends on retention improving; the two compound.</a:t>
+              <a:t>◦ Personalization reach is small today (~3%), and growing it depends on retention improving; the two compound.</a:t>
             </a:r>
           </a:p>
           <a:p>

</xml_diff>